<commit_message>
Update presentation file with latest changes
</commit_message>
<xml_diff>
--- a/docs/PR/LT/HomePage_開発者用.pptx
+++ b/docs/PR/LT/HomePage_開発者用.pptx
@@ -5,7 +5,7 @@
     <p:sldMasterId id="2147483648" r:id="rId1"/>
   </p:sldMasterIdLst>
   <p:notesMasterIdLst>
-    <p:notesMasterId r:id="rId11"/>
+    <p:notesMasterId r:id="rId12"/>
   </p:notesMasterIdLst>
   <p:sldIdLst>
     <p:sldId id="256" r:id="rId2"/>
@@ -17,6 +17,7 @@
     <p:sldId id="269" r:id="rId8"/>
     <p:sldId id="270" r:id="rId9"/>
     <p:sldId id="271" r:id="rId10"/>
+    <p:sldId id="273" r:id="rId11"/>
   </p:sldIdLst>
   <p:sldSz cx="12192000" cy="6858000"/>
   <p:notesSz cx="6858000" cy="9144000"/>
@@ -216,7 +217,7 @@
           <a:p>
             <a:fld id="{B5390508-11FE-4107-B12B-FCBF7DE7140E}" type="datetimeFigureOut">
               <a:rPr kumimoji="1" lang="ja-JP" altLang="en-US" smtClean="0"/>
-              <a:t>2026/4/8</a:t>
+              <a:t>2026/4/10</a:t>
             </a:fld>
             <a:endParaRPr kumimoji="1" lang="ja-JP" altLang="en-US"/>
           </a:p>
@@ -2267,6 +2268,90 @@
 </p:notes>
 </file>
 
+<file path=ppt/notesSlides/notesSlide2.xml><?xml version="1.0" encoding="utf-8"?>
+<p:notes xmlns:a="http://schemas.openxmlformats.org/drawingml/2006/main" xmlns:r="http://schemas.openxmlformats.org/officeDocument/2006/relationships" xmlns:p="http://schemas.openxmlformats.org/presentationml/2006/main">
+  <p:cSld>
+    <p:spTree>
+      <p:nvGrpSpPr>
+        <p:cNvPr id="1" name=""/>
+        <p:cNvGrpSpPr/>
+        <p:nvPr/>
+      </p:nvGrpSpPr>
+      <p:grpSpPr>
+        <a:xfrm>
+          <a:off x="0" y="0"/>
+          <a:ext cx="0" cy="0"/>
+          <a:chOff x="0" y="0"/>
+          <a:chExt cx="0" cy="0"/>
+        </a:xfrm>
+      </p:grpSpPr>
+      <p:sp>
+        <p:nvSpPr>
+          <p:cNvPr id="2" name="スライド イメージ プレースホルダー 1"/>
+          <p:cNvSpPr>
+            <a:spLocks noGrp="1" noRot="1" noChangeAspect="1"/>
+          </p:cNvSpPr>
+          <p:nvPr>
+            <p:ph type="sldImg"/>
+          </p:nvPr>
+        </p:nvSpPr>
+        <p:spPr/>
+      </p:sp>
+      <p:sp>
+        <p:nvSpPr>
+          <p:cNvPr id="3" name="ノート プレースホルダー 2"/>
+          <p:cNvSpPr>
+            <a:spLocks noGrp="1"/>
+          </p:cNvSpPr>
+          <p:nvPr>
+            <p:ph type="body" idx="1"/>
+          </p:nvPr>
+        </p:nvSpPr>
+        <p:spPr/>
+        <p:txBody>
+          <a:bodyPr/>
+          <a:lstStyle/>
+          <a:p>
+            <a:endParaRPr kumimoji="1" lang="ja-JP" altLang="en-US" dirty="0"/>
+          </a:p>
+        </p:txBody>
+      </p:sp>
+      <p:sp>
+        <p:nvSpPr>
+          <p:cNvPr id="4" name="スライド番号プレースホルダー 3"/>
+          <p:cNvSpPr>
+            <a:spLocks noGrp="1"/>
+          </p:cNvSpPr>
+          <p:nvPr>
+            <p:ph type="sldNum" sz="quarter" idx="5"/>
+          </p:nvPr>
+        </p:nvSpPr>
+        <p:spPr/>
+        <p:txBody>
+          <a:bodyPr/>
+          <a:lstStyle/>
+          <a:p>
+            <a:fld id="{FE40D1D6-3BC6-4DF1-B693-2708FA121648}" type="slidenum">
+              <a:rPr kumimoji="1" lang="ja-JP" altLang="en-US" smtClean="0"/>
+              <a:t>8</a:t>
+            </a:fld>
+            <a:endParaRPr kumimoji="1" lang="ja-JP" altLang="en-US"/>
+          </a:p>
+        </p:txBody>
+      </p:sp>
+    </p:spTree>
+    <p:extLst>
+      <p:ext uri="{BB962C8B-B14F-4D97-AF65-F5344CB8AC3E}">
+        <p14:creationId xmlns:p14="http://schemas.microsoft.com/office/powerpoint/2010/main" val="277506193"/>
+      </p:ext>
+    </p:extLst>
+  </p:cSld>
+  <p:clrMapOvr>
+    <a:masterClrMapping/>
+  </p:clrMapOvr>
+</p:notes>
+</file>
+
 <file path=ppt/slideLayouts/slideLayout1.xml><?xml version="1.0" encoding="utf-8"?>
 <p:sldLayout xmlns:a="http://schemas.openxmlformats.org/drawingml/2006/main" xmlns:r="http://schemas.openxmlformats.org/officeDocument/2006/relationships" xmlns:p="http://schemas.openxmlformats.org/presentationml/2006/main" type="title" preserve="1">
   <p:cSld name="Title Slide">
@@ -2446,7 +2531,7 @@
           <a:p>
             <a:fld id="{5BCAD085-E8A6-8845-BD4E-CB4CCA059FC4}" type="datetimeFigureOut">
               <a:rPr lang="en-US" smtClean="0"/>
-              <a:t>4/8/2026</a:t>
+              <a:t>4/10/2026</a:t>
             </a:fld>
             <a:endParaRPr lang="en-US"/>
           </a:p>
@@ -2614,7 +2699,7 @@
           <a:p>
             <a:fld id="{5BCAD085-E8A6-8845-BD4E-CB4CCA059FC4}" type="datetimeFigureOut">
               <a:rPr lang="en-US" smtClean="0"/>
-              <a:t>4/8/2026</a:t>
+              <a:t>4/10/2026</a:t>
             </a:fld>
             <a:endParaRPr lang="en-US"/>
           </a:p>
@@ -2792,7 +2877,7 @@
           <a:p>
             <a:fld id="{5BCAD085-E8A6-8845-BD4E-CB4CCA059FC4}" type="datetimeFigureOut">
               <a:rPr lang="en-US" smtClean="0"/>
-              <a:t>4/8/2026</a:t>
+              <a:t>4/10/2026</a:t>
             </a:fld>
             <a:endParaRPr lang="en-US"/>
           </a:p>
@@ -2960,7 +3045,7 @@
           <a:p>
             <a:fld id="{5BCAD085-E8A6-8845-BD4E-CB4CCA059FC4}" type="datetimeFigureOut">
               <a:rPr lang="en-US" smtClean="0"/>
-              <a:t>4/8/2026</a:t>
+              <a:t>4/10/2026</a:t>
             </a:fld>
             <a:endParaRPr lang="en-US"/>
           </a:p>
@@ -3205,7 +3290,7 @@
           <a:p>
             <a:fld id="{5BCAD085-E8A6-8845-BD4E-CB4CCA059FC4}" type="datetimeFigureOut">
               <a:rPr lang="en-US" smtClean="0"/>
-              <a:t>4/8/2026</a:t>
+              <a:t>4/10/2026</a:t>
             </a:fld>
             <a:endParaRPr lang="en-US"/>
           </a:p>
@@ -3490,7 +3575,7 @@
           <a:p>
             <a:fld id="{5BCAD085-E8A6-8845-BD4E-CB4CCA059FC4}" type="datetimeFigureOut">
               <a:rPr lang="en-US" smtClean="0"/>
-              <a:t>4/8/2026</a:t>
+              <a:t>4/10/2026</a:t>
             </a:fld>
             <a:endParaRPr lang="en-US"/>
           </a:p>
@@ -3909,7 +3994,7 @@
           <a:p>
             <a:fld id="{5BCAD085-E8A6-8845-BD4E-CB4CCA059FC4}" type="datetimeFigureOut">
               <a:rPr lang="en-US" smtClean="0"/>
-              <a:t>4/8/2026</a:t>
+              <a:t>4/10/2026</a:t>
             </a:fld>
             <a:endParaRPr lang="en-US"/>
           </a:p>
@@ -4026,7 +4111,7 @@
           <a:p>
             <a:fld id="{5BCAD085-E8A6-8845-BD4E-CB4CCA059FC4}" type="datetimeFigureOut">
               <a:rPr lang="en-US" smtClean="0"/>
-              <a:t>4/8/2026</a:t>
+              <a:t>4/10/2026</a:t>
             </a:fld>
             <a:endParaRPr lang="en-US"/>
           </a:p>
@@ -4121,7 +4206,7 @@
           <a:p>
             <a:fld id="{5BCAD085-E8A6-8845-BD4E-CB4CCA059FC4}" type="datetimeFigureOut">
               <a:rPr lang="en-US" smtClean="0"/>
-              <a:t>4/8/2026</a:t>
+              <a:t>4/10/2026</a:t>
             </a:fld>
             <a:endParaRPr lang="en-US"/>
           </a:p>
@@ -4396,7 +4481,7 @@
           <a:p>
             <a:fld id="{5BCAD085-E8A6-8845-BD4E-CB4CCA059FC4}" type="datetimeFigureOut">
               <a:rPr lang="en-US" smtClean="0"/>
-              <a:t>4/8/2026</a:t>
+              <a:t>4/10/2026</a:t>
             </a:fld>
             <a:endParaRPr lang="en-US"/>
           </a:p>
@@ -4648,7 +4733,7 @@
           <a:p>
             <a:fld id="{5BCAD085-E8A6-8845-BD4E-CB4CCA059FC4}" type="datetimeFigureOut">
               <a:rPr lang="en-US" smtClean="0"/>
-              <a:t>4/8/2026</a:t>
+              <a:t>4/10/2026</a:t>
             </a:fld>
             <a:endParaRPr lang="en-US"/>
           </a:p>
@@ -4859,7 +4944,7 @@
           <a:p>
             <a:fld id="{5BCAD085-E8A6-8845-BD4E-CB4CCA059FC4}" type="datetimeFigureOut">
               <a:rPr lang="en-US" smtClean="0"/>
-              <a:t>4/8/2026</a:t>
+              <a:t>4/10/2026</a:t>
             </a:fld>
             <a:endParaRPr lang="en-US"/>
           </a:p>
@@ -5250,7 +5335,7 @@
         </p:nvSpPr>
         <p:spPr>
           <a:xfrm>
-            <a:off x="800000" y="1500000"/>
+            <a:off x="800000" y="2105561"/>
             <a:ext cx="10591695" cy="1323439"/>
           </a:xfrm>
           <a:prstGeom prst="rect">
@@ -5288,58 +5373,6 @@
             <a:r>
               <a:rPr sz="4000" dirty="0"/>
               <a:t>5日間でホームページを作った話</a:t>
-            </a:r>
-          </a:p>
-        </p:txBody>
-      </p:sp>
-      <p:sp>
-        <p:nvSpPr>
-          <p:cNvPr id="3" name="TextBox 2"/>
-          <p:cNvSpPr txBox="1"/>
-          <p:nvPr/>
-        </p:nvSpPr>
-        <p:spPr>
-          <a:xfrm>
-            <a:off x="800000" y="2800000"/>
-            <a:ext cx="10591695" cy="523220"/>
-          </a:xfrm>
-          <a:prstGeom prst="rect">
-            <a:avLst/>
-          </a:prstGeom>
-          <a:noFill/>
-        </p:spPr>
-        <p:txBody>
-          <a:bodyPr wrap="square">
-            <a:spAutoFit/>
-          </a:bodyPr>
-          <a:lstStyle/>
-          <a:p>
-            <a:pPr algn="ctr">
-              <a:defRPr sz="2000" b="0">
-                <a:solidFill>
-                  <a:srgbClr val="A78BFA"/>
-                </a:solidFill>
-              </a:defRPr>
-            </a:pPr>
-            <a:r>
-              <a:rPr dirty="0"/>
-              <a:t>— </a:t>
-            </a:r>
-            <a:r>
-              <a:rPr sz="2800" dirty="0" err="1"/>
-              <a:t>HomePage</a:t>
-            </a:r>
-            <a:r>
-              <a:rPr dirty="0"/>
-              <a:t> </a:t>
-            </a:r>
-            <a:r>
-              <a:rPr dirty="0" err="1"/>
-              <a:t>開発記</a:t>
-            </a:r>
-            <a:r>
-              <a:rPr dirty="0"/>
-              <a:t> —</a:t>
             </a:r>
           </a:p>
         </p:txBody>
@@ -5359,7 +5392,7 @@
         <p:spPr>
           <a:xfrm>
             <a:off x="800000" y="3563816"/>
-            <a:ext cx="10591695" cy="400110"/>
+            <a:ext cx="10591695" cy="523220"/>
           </a:xfrm>
           <a:prstGeom prst="rect">
             <a:avLst/>
@@ -5380,14 +5413,144 @@
               </a:defRPr>
             </a:pPr>
             <a:r>
-              <a:rPr lang="ja-JP" altLang="en-US" dirty="0"/>
+              <a:rPr lang="ja-JP" altLang="en-US" sz="2800" dirty="0"/>
               <a:t>須山 哲平</a:t>
             </a:r>
-            <a:endParaRPr dirty="0"/>
+            <a:endParaRPr sz="2800" dirty="0"/>
           </a:p>
         </p:txBody>
       </p:sp>
     </p:spTree>
+  </p:cSld>
+  <p:clrMapOvr>
+    <a:masterClrMapping/>
+  </p:clrMapOvr>
+</p:sld>
+</file>
+
+<file path=ppt/slides/slide10.xml><?xml version="1.0" encoding="utf-8"?>
+<p:sld xmlns:a="http://schemas.openxmlformats.org/drawingml/2006/main" xmlns:r="http://schemas.openxmlformats.org/officeDocument/2006/relationships" xmlns:p="http://schemas.openxmlformats.org/presentationml/2006/main">
+  <p:cSld>
+    <p:bg>
+      <p:bgPr>
+        <a:solidFill>
+          <a:srgbClr val="0F172A"/>
+        </a:solidFill>
+        <a:effectLst/>
+      </p:bgPr>
+    </p:bg>
+    <p:spTree>
+      <p:nvGrpSpPr>
+        <p:cNvPr id="1" name="">
+          <a:extLst>
+            <a:ext uri="{FF2B5EF4-FFF2-40B4-BE49-F238E27FC236}">
+              <a16:creationId xmlns:a16="http://schemas.microsoft.com/office/drawing/2014/main" id="{776768AF-0C0A-8CBD-5448-0A1D9039F05E}"/>
+            </a:ext>
+          </a:extLst>
+        </p:cNvPr>
+        <p:cNvGrpSpPr/>
+        <p:nvPr/>
+      </p:nvGrpSpPr>
+      <p:grpSpPr>
+        <a:xfrm>
+          <a:off x="0" y="0"/>
+          <a:ext cx="0" cy="0"/>
+          <a:chOff x="0" y="0"/>
+          <a:chExt cx="0" cy="0"/>
+        </a:xfrm>
+      </p:grpSpPr>
+      <p:sp>
+        <p:nvSpPr>
+          <p:cNvPr id="2" name="TextBox 1">
+            <a:extLst>
+              <a:ext uri="{FF2B5EF4-FFF2-40B4-BE49-F238E27FC236}">
+                <a16:creationId xmlns:a16="http://schemas.microsoft.com/office/drawing/2014/main" id="{BF2089D5-455D-5512-E005-46563C7FFA83}"/>
+              </a:ext>
+            </a:extLst>
+          </p:cNvPr>
+          <p:cNvSpPr txBox="1"/>
+          <p:nvPr/>
+        </p:nvSpPr>
+        <p:spPr>
+          <a:xfrm>
+            <a:off x="800000" y="2568342"/>
+            <a:ext cx="10591695" cy="707886"/>
+          </a:xfrm>
+          <a:prstGeom prst="rect">
+            <a:avLst/>
+          </a:prstGeom>
+          <a:noFill/>
+        </p:spPr>
+        <p:txBody>
+          <a:bodyPr wrap="square">
+            <a:spAutoFit/>
+          </a:bodyPr>
+          <a:lstStyle/>
+          <a:p>
+            <a:pPr algn="ctr">
+              <a:defRPr sz="3200" b="1">
+                <a:solidFill>
+                  <a:srgbClr val="60A5FA"/>
+                </a:solidFill>
+              </a:defRPr>
+            </a:pPr>
+            <a:r>
+              <a:rPr lang="ja-JP" altLang="en-US" sz="4000" dirty="0"/>
+              <a:t>ご清聴ありがとうございました</a:t>
+            </a:r>
+            <a:endParaRPr sz="4000" dirty="0"/>
+          </a:p>
+        </p:txBody>
+      </p:sp>
+      <p:sp>
+        <p:nvSpPr>
+          <p:cNvPr id="4" name="TextBox 2">
+            <a:extLst>
+              <a:ext uri="{FF2B5EF4-FFF2-40B4-BE49-F238E27FC236}">
+                <a16:creationId xmlns:a16="http://schemas.microsoft.com/office/drawing/2014/main" id="{4C967B40-6251-4914-278D-1C30B7CF87A3}"/>
+              </a:ext>
+            </a:extLst>
+          </p:cNvPr>
+          <p:cNvSpPr txBox="1"/>
+          <p:nvPr/>
+        </p:nvSpPr>
+        <p:spPr>
+          <a:xfrm>
+            <a:off x="800000" y="3563816"/>
+            <a:ext cx="10591695" cy="523220"/>
+          </a:xfrm>
+          <a:prstGeom prst="rect">
+            <a:avLst/>
+          </a:prstGeom>
+          <a:noFill/>
+        </p:spPr>
+        <p:txBody>
+          <a:bodyPr wrap="square">
+            <a:spAutoFit/>
+          </a:bodyPr>
+          <a:lstStyle/>
+          <a:p>
+            <a:pPr algn="ctr">
+              <a:defRPr sz="2000" b="0">
+                <a:solidFill>
+                  <a:srgbClr val="A78BFA"/>
+                </a:solidFill>
+              </a:defRPr>
+            </a:pPr>
+            <a:r>
+              <a:rPr lang="ja-JP" altLang="en-US" sz="2800" dirty="0"/>
+              <a:t>須山 哲平</a:t>
+            </a:r>
+            <a:endParaRPr sz="2800" dirty="0"/>
+          </a:p>
+        </p:txBody>
+      </p:sp>
+    </p:spTree>
+    <p:extLst>
+      <p:ext uri="{BB962C8B-B14F-4D97-AF65-F5344CB8AC3E}">
+        <p14:creationId xmlns:p14="http://schemas.microsoft.com/office/powerpoint/2010/main" val="1552236356"/>
+      </p:ext>
+    </p:extLst>
   </p:cSld>
   <p:clrMapOvr>
     <a:masterClrMapping/>
@@ -5515,7 +5678,7 @@
         <p:spPr>
           <a:xfrm>
             <a:off x="960120" y="1234440"/>
-            <a:ext cx="5166360" cy="4754880"/>
+            <a:ext cx="5166360" cy="2862322"/>
           </a:xfrm>
           <a:prstGeom prst="rect">
             <a:avLst/>
@@ -5530,7 +5693,7 @@
           <a:p>
             <a:pPr algn="l"/>
             <a:r>
-              <a:rPr sz="1200" b="1">
+              <a:rPr sz="1200" b="1" dirty="0">
                 <a:solidFill>
                   <a:srgbClr val="A78BFA"/>
                 </a:solidFill>
@@ -5542,7 +5705,7 @@
           <a:p>
             <a:pPr algn="l"/>
             <a:r>
-              <a:rPr sz="2000" b="1">
+              <a:rPr sz="2000" b="1" dirty="0">
                 <a:solidFill>
                   <a:srgbClr val="E2E8F0"/>
                 </a:solidFill>
@@ -5554,18 +5717,42 @@
           <a:p>
             <a:pPr algn="l"/>
             <a:r>
-              <a:rPr sz="1300" b="0">
+              <a:rPr sz="1300" b="0" dirty="0">
                 <a:solidFill>
                   <a:srgbClr val="94A3B8"/>
                 </a:solidFill>
                 <a:latin typeface="Yu Gothic UI"/>
               </a:rPr>
-              <a:t>27歳 / IT業界 5年目 / 副業エンジニア</a:t>
-            </a:r>
-          </a:p>
-          <a:p>
-            <a:pPr algn="l"/>
-            <a:endParaRPr sz="1300" b="0">
+              <a:t>27歳 / </a:t>
+            </a:r>
+            <a:r>
+              <a:rPr sz="1300" b="0" dirty="0" err="1">
+                <a:solidFill>
+                  <a:srgbClr val="94A3B8"/>
+                </a:solidFill>
+                <a:latin typeface="Yu Gothic UI"/>
+              </a:rPr>
+              <a:t>IT業界</a:t>
+            </a:r>
+            <a:r>
+              <a:rPr sz="1300" b="0" dirty="0">
+                <a:solidFill>
+                  <a:srgbClr val="94A3B8"/>
+                </a:solidFill>
+                <a:latin typeface="Yu Gothic UI"/>
+              </a:rPr>
+              <a:t> 5年目 / </a:t>
+            </a:r>
+            <a:r>
+              <a:rPr sz="1300" b="0" dirty="0" err="1">
+                <a:solidFill>
+                  <a:srgbClr val="94A3B8"/>
+                </a:solidFill>
+                <a:latin typeface="Yu Gothic UI"/>
+              </a:rPr>
+              <a:t>エンジニア</a:t>
+            </a:r>
+            <a:endParaRPr sz="1300" b="0" dirty="0">
               <a:solidFill>
                 <a:srgbClr val="94A3B8"/>
               </a:solidFill>
@@ -5574,8 +5761,17 @@
           </a:p>
           <a:p>
             <a:pPr algn="l"/>
-            <a:r>
-              <a:rPr sz="1200" b="1">
+            <a:endParaRPr sz="1300" b="0" dirty="0">
+              <a:solidFill>
+                <a:srgbClr val="94A3B8"/>
+              </a:solidFill>
+              <a:latin typeface="Yu Gothic UI"/>
+            </a:endParaRPr>
+          </a:p>
+          <a:p>
+            <a:pPr algn="l"/>
+            <a:r>
+              <a:rPr sz="1200" b="1" dirty="0">
                 <a:solidFill>
                   <a:srgbClr val="A78BFA"/>
                 </a:solidFill>
@@ -5587,7 +5783,7 @@
           <a:p>
             <a:pPr algn="l"/>
             <a:r>
-              <a:rPr sz="1300" b="0">
+              <a:rPr sz="1300" b="0" dirty="0">
                 <a:solidFill>
                   <a:srgbClr val="E2E8F0"/>
                 </a:solidFill>
@@ -5599,30 +5795,102 @@
           <a:p>
             <a:pPr algn="l"/>
             <a:r>
-              <a:rPr sz="1300" b="0">
+              <a:rPr sz="1300" b="0" dirty="0">
                 <a:solidFill>
                   <a:srgbClr val="E2E8F0"/>
                 </a:solidFill>
                 <a:latin typeface="Yu Gothic UI"/>
               </a:rPr>
-              <a:t>• SES（現職 / フルスタック）</a:t>
+              <a:t>• </a:t>
+            </a:r>
+            <a:r>
+              <a:rPr sz="1300" b="0" dirty="0" err="1">
+                <a:solidFill>
+                  <a:srgbClr val="E2E8F0"/>
+                </a:solidFill>
+                <a:latin typeface="Yu Gothic UI"/>
+              </a:rPr>
+              <a:t>SES（現職</a:t>
+            </a:r>
+            <a:r>
+              <a:rPr sz="1300" b="0" dirty="0">
+                <a:solidFill>
+                  <a:srgbClr val="E2E8F0"/>
+                </a:solidFill>
+                <a:latin typeface="Yu Gothic UI"/>
+              </a:rPr>
+              <a:t> / </a:t>
+            </a:r>
+            <a:r>
+              <a:rPr sz="1300" b="0" dirty="0" err="1">
+                <a:solidFill>
+                  <a:srgbClr val="E2E8F0"/>
+                </a:solidFill>
+                <a:latin typeface="Yu Gothic UI"/>
+              </a:rPr>
+              <a:t>フルスタック</a:t>
+            </a:r>
+            <a:r>
+              <a:rPr sz="1300" b="0" dirty="0">
+                <a:solidFill>
+                  <a:srgbClr val="E2E8F0"/>
+                </a:solidFill>
+                <a:latin typeface="Yu Gothic UI"/>
+              </a:rPr>
+              <a:t>）</a:t>
             </a:r>
           </a:p>
           <a:p>
             <a:pPr algn="l"/>
             <a:r>
-              <a:rPr sz="1300" b="0">
+              <a:rPr sz="1300" b="0" dirty="0">
                 <a:solidFill>
                   <a:srgbClr val="E2E8F0"/>
                 </a:solidFill>
                 <a:latin typeface="Yu Gothic UI"/>
               </a:rPr>
-              <a:t>• 業務委託 副業（約1年）</a:t>
+              <a:t>• </a:t>
+            </a:r>
+            <a:r>
+              <a:rPr sz="1300" b="0" dirty="0" err="1">
+                <a:solidFill>
+                  <a:srgbClr val="E2E8F0"/>
+                </a:solidFill>
+                <a:latin typeface="Yu Gothic UI"/>
+              </a:rPr>
+              <a:t>業務委託</a:t>
+            </a:r>
+            <a:r>
+              <a:rPr sz="1300" b="0" dirty="0">
+                <a:solidFill>
+                  <a:srgbClr val="E2E8F0"/>
+                </a:solidFill>
+                <a:latin typeface="Yu Gothic UI"/>
+              </a:rPr>
+              <a:t> 副業（1年</a:t>
+            </a:r>
+            <a:r>
+              <a:rPr lang="ja-JP" altLang="en-US" sz="1300" b="0" dirty="0">
+                <a:solidFill>
+                  <a:srgbClr val="E2E8F0"/>
+                </a:solidFill>
+                <a:latin typeface="Yu Gothic UI"/>
+              </a:rPr>
+              <a:t>目</a:t>
+            </a:r>
+            <a:r>
+              <a:rPr sz="1300" b="0" dirty="0">
+                <a:solidFill>
+                  <a:srgbClr val="E2E8F0"/>
+                </a:solidFill>
+                <a:latin typeface="Yu Gothic UI"/>
+              </a:rPr>
+              <a:t>）</a:t>
             </a:r>
           </a:p>
           <a:p>
             <a:pPr algn="l"/>
-            <a:endParaRPr sz="1300" b="0">
+            <a:endParaRPr sz="1300" b="0" dirty="0">
               <a:solidFill>
                 <a:srgbClr val="E2E8F0"/>
               </a:solidFill>
@@ -5632,49 +5900,145 @@
           <a:p>
             <a:pPr algn="l"/>
             <a:r>
-              <a:rPr sz="1200" b="1">
+              <a:rPr sz="1200" b="1" dirty="0" err="1">
                 <a:solidFill>
                   <a:srgbClr val="A78BFA"/>
                 </a:solidFill>
                 <a:latin typeface="Yu Gothic UI"/>
               </a:rPr>
-              <a:t>AI駆動開発 個人開発実績</a:t>
-            </a:r>
+              <a:t>AI駆動開発</a:t>
+            </a:r>
+            <a:r>
+              <a:rPr sz="1200" b="1" dirty="0">
+                <a:solidFill>
+                  <a:srgbClr val="A78BFA"/>
+                </a:solidFill>
+                <a:latin typeface="Yu Gothic UI"/>
+              </a:rPr>
+              <a:t> </a:t>
+            </a:r>
+            <a:r>
+              <a:rPr sz="1200" b="1" dirty="0" err="1">
+                <a:solidFill>
+                  <a:srgbClr val="A78BFA"/>
+                </a:solidFill>
+                <a:latin typeface="Yu Gothic UI"/>
+              </a:rPr>
+              <a:t>個人開発実績</a:t>
+            </a:r>
+            <a:endParaRPr sz="1200" b="1" dirty="0">
+              <a:solidFill>
+                <a:srgbClr val="A78BFA"/>
+              </a:solidFill>
+              <a:latin typeface="Yu Gothic UI"/>
+            </a:endParaRPr>
           </a:p>
           <a:p>
             <a:pPr algn="l"/>
             <a:r>
-              <a:rPr sz="1300" b="0">
+              <a:rPr sz="1300" b="0" dirty="0">
                 <a:solidFill>
                   <a:srgbClr val="E2E8F0"/>
                 </a:solidFill>
                 <a:latin typeface="Yu Gothic UI"/>
               </a:rPr>
-              <a:t>① ユメハシ (Flutter/Dart)  ──  21日</a:t>
+              <a:t>① </a:t>
+            </a:r>
+            <a:r>
+              <a:rPr sz="1300" b="0" dirty="0" err="1">
+                <a:solidFill>
+                  <a:srgbClr val="E2E8F0"/>
+                </a:solidFill>
+                <a:latin typeface="Yu Gothic UI"/>
+              </a:rPr>
+              <a:t>ユメハシ</a:t>
+            </a:r>
+            <a:r>
+              <a:rPr sz="1300" b="0" dirty="0">
+                <a:solidFill>
+                  <a:srgbClr val="E2E8F0"/>
+                </a:solidFill>
+                <a:latin typeface="Yu Gothic UI"/>
+              </a:rPr>
+              <a:t> (Flutter/Dart)  ──  21日</a:t>
             </a:r>
           </a:p>
           <a:p>
             <a:pPr algn="l"/>
             <a:r>
-              <a:rPr sz="1300" b="0">
+              <a:rPr sz="1300" b="0" dirty="0">
                 <a:solidFill>
                   <a:srgbClr val="E2E8F0"/>
                 </a:solidFill>
                 <a:latin typeface="Yu Gothic UI"/>
               </a:rPr>
-              <a:t>② Defrago (Python/FastAPI)  ──  14日</a:t>
+              <a:t>② </a:t>
+            </a:r>
+            <a:r>
+              <a:rPr sz="1300" b="0" dirty="0" err="1">
+                <a:solidFill>
+                  <a:srgbClr val="E2E8F0"/>
+                </a:solidFill>
+                <a:latin typeface="Yu Gothic UI"/>
+              </a:rPr>
+              <a:t>Defrago</a:t>
+            </a:r>
+            <a:r>
+              <a:rPr sz="1300" b="0" dirty="0">
+                <a:solidFill>
+                  <a:srgbClr val="E2E8F0"/>
+                </a:solidFill>
+                <a:latin typeface="Yu Gothic UI"/>
+              </a:rPr>
+              <a:t> (Python/</a:t>
+            </a:r>
+            <a:r>
+              <a:rPr sz="1300" b="0" dirty="0" err="1">
+                <a:solidFill>
+                  <a:srgbClr val="E2E8F0"/>
+                </a:solidFill>
+                <a:latin typeface="Yu Gothic UI"/>
+              </a:rPr>
+              <a:t>FastAPI</a:t>
+            </a:r>
+            <a:r>
+              <a:rPr sz="1300" b="0" dirty="0">
+                <a:solidFill>
+                  <a:srgbClr val="E2E8F0"/>
+                </a:solidFill>
+                <a:latin typeface="Yu Gothic UI"/>
+              </a:rPr>
+              <a:t>)  ──  14日</a:t>
             </a:r>
           </a:p>
           <a:p>
             <a:pPr algn="l"/>
             <a:r>
-              <a:rPr sz="1400" b="1">
+              <a:rPr sz="1400" b="1" dirty="0">
                 <a:solidFill>
                   <a:srgbClr val="60A5FA"/>
                 </a:solidFill>
                 <a:latin typeface="Yu Gothic UI"/>
               </a:rPr>
-              <a:t>③ HomePage (Astro/TS)  ──  5日  ← 本LT題材</a:t>
+              <a:t>③ </a:t>
+            </a:r>
+            <a:r>
+              <a:rPr sz="1400" b="1" dirty="0" err="1">
+                <a:solidFill>
+                  <a:srgbClr val="60A5FA"/>
+                </a:solidFill>
+                <a:latin typeface="Yu Gothic UI"/>
+              </a:rPr>
+              <a:t>HomePage</a:t>
+            </a:r>
+            <a:r>
+              <a:rPr sz="1400" b="1" dirty="0">
+                <a:solidFill>
+                  <a:srgbClr val="60A5FA"/>
+                </a:solidFill>
+                <a:latin typeface="Yu Gothic UI"/>
+              </a:rPr>
+              <a:t> (Astro/TS)  ──  5日</a:t>
             </a:r>
           </a:p>
         </p:txBody>
@@ -11738,7 +12102,7 @@
         <p:spPr>
           <a:xfrm>
             <a:off x="8183879" y="4023360"/>
-            <a:ext cx="3108960" cy="1645920"/>
+            <a:ext cx="3108960" cy="738664"/>
           </a:xfrm>
           <a:prstGeom prst="rect">
             <a:avLst/>
@@ -11753,38 +12117,95 @@
           <a:p>
             <a:pPr algn="l"/>
             <a:r>
-              <a:rPr sz="1200" b="0">
+              <a:rPr sz="1200" b="0" dirty="0" err="1">
                 <a:solidFill>
                   <a:srgbClr val="E2E8F0"/>
                 </a:solidFill>
                 <a:latin typeface="Yu Gothic UI"/>
               </a:rPr>
-              <a:t>Qiita 記事をビルド時に自動取得。</a:t>
+              <a:t>Qiita</a:t>
+            </a:r>
+            <a:r>
+              <a:rPr sz="1200" b="0" dirty="0">
+                <a:solidFill>
+                  <a:srgbClr val="E2E8F0"/>
+                </a:solidFill>
+                <a:latin typeface="Yu Gothic UI"/>
+              </a:rPr>
+              <a:t> </a:t>
+            </a:r>
+            <a:r>
+              <a:rPr sz="1200" b="0" dirty="0" err="1">
+                <a:solidFill>
+                  <a:srgbClr val="E2E8F0"/>
+                </a:solidFill>
+                <a:latin typeface="Yu Gothic UI"/>
+              </a:rPr>
+              <a:t>記事をビルド時に自動取得</a:t>
+            </a:r>
+            <a:r>
+              <a:rPr sz="1200" b="0" dirty="0">
+                <a:solidFill>
+                  <a:srgbClr val="E2E8F0"/>
+                </a:solidFill>
+                <a:latin typeface="Yu Gothic UI"/>
+              </a:rPr>
+              <a:t>。</a:t>
             </a:r>
           </a:p>
           <a:p>
             <a:pPr algn="l"/>
             <a:r>
-              <a:rPr sz="1200" b="0">
+              <a:rPr lang="ja-JP" altLang="en-US" sz="1200" b="0" dirty="0">
                 <a:solidFill>
                   <a:srgbClr val="E2E8F0"/>
                 </a:solidFill>
                 <a:latin typeface="Yu Gothic UI"/>
               </a:rPr>
-              <a:t>Work &amp; Dev / Essay / Tech の3軸で</a:t>
-            </a:r>
-          </a:p>
-          <a:p>
-            <a:pPr algn="l"/>
-            <a:r>
-              <a:rPr sz="1200" b="0">
+              <a:t>毎日の投稿予約機能等を用いることで</a:t>
+            </a:r>
+            <a:r>
+              <a:rPr lang="en-US" altLang="ja-JP" sz="1200" b="0" dirty="0">
                 <a:solidFill>
                   <a:srgbClr val="E2E8F0"/>
                 </a:solidFill>
                 <a:latin typeface="Yu Gothic UI"/>
               </a:rPr>
-              <a:t>発信を継続できる仕組み。</a:t>
-            </a:r>
+              <a:t>1</a:t>
+            </a:r>
+            <a:r>
+              <a:rPr lang="ja-JP" altLang="en-US" sz="1200" b="0" dirty="0">
+                <a:solidFill>
+                  <a:srgbClr val="E2E8F0"/>
+                </a:solidFill>
+                <a:latin typeface="Yu Gothic UI"/>
+              </a:rPr>
+              <a:t>日</a:t>
+            </a:r>
+            <a:r>
+              <a:rPr lang="en-US" altLang="ja-JP" sz="1200" b="0" dirty="0">
+                <a:solidFill>
+                  <a:srgbClr val="E2E8F0"/>
+                </a:solidFill>
+                <a:latin typeface="Yu Gothic UI"/>
+              </a:rPr>
+              <a:t>1</a:t>
+            </a:r>
+            <a:r>
+              <a:rPr lang="ja-JP" altLang="en-US" sz="1200" b="0" dirty="0">
+                <a:solidFill>
+                  <a:srgbClr val="E2E8F0"/>
+                </a:solidFill>
+                <a:latin typeface="Yu Gothic UI"/>
+              </a:rPr>
+              <a:t>投稿を目指す。</a:t>
+            </a:r>
+            <a:endParaRPr sz="1200" b="0" dirty="0">
+              <a:solidFill>
+                <a:srgbClr val="E2E8F0"/>
+              </a:solidFill>
+              <a:latin typeface="Yu Gothic UI"/>
+            </a:endParaRPr>
           </a:p>
         </p:txBody>
       </p:sp>

</xml_diff>